<commit_message>
feat(QRFG): update Build Deck — expanded tech stack + infra costs on offer slide
</commit_message>
<xml_diff>
--- a/SELLL-Engine/QRFloorGenie-Build-Deck.pptx
+++ b/SELLL-Engine/QRFloorGenie-Build-Deck.pptx
@@ -8872,7 +8872,7 @@
                   <a:srgbClr val="888899"/>
                 </a:solidFill>
               </a:rPr>
-              <a:t>You own and fund these tools.</a:t>
+              <a:t>You own and fund these. SELLL handles all setup and configuration.</a:t>
             </a:r>
           </a:p>
         </p:txBody>
@@ -8983,7 +8983,7 @@
                   <a:srgbClr val="CCCCD8"/>
                 </a:solidFill>
               </a:rPr>
-              <a:t>Already owned  —  contact data source</a:t>
+              <a:t>Existing  —  contact data rebuilt + segmented by SELLL</a:t>
             </a:r>
           </a:p>
         </p:txBody>
@@ -9094,7 +9094,7 @@
                   <a:srgbClr val="CCCCD8"/>
                 </a:solidFill>
               </a:rPr>
-              <a:t>Already owned  —  email sequences rebuilt by SELLL</a:t>
+              <a:t>Existing  —  sequences rebuilt + warmup configured by SELLL</a:t>
             </a:r>
           </a:p>
         </p:txBody>
@@ -9205,7 +9205,7 @@
                   <a:srgbClr val="CCCCD8"/>
                 </a:solidFill>
               </a:rPr>
-              <a:t>Already owned  —  signal source + contact finding</a:t>
+              <a:t>Existing  —  signal source + contact enrichment</a:t>
             </a:r>
           </a:p>
         </p:txBody>
@@ -9316,7 +9316,7 @@
                   <a:srgbClr val="CCCCD8"/>
                 </a:solidFill>
               </a:rPr>
-              <a:t>New  $149-349/mo  —  enrichment engine</a:t>
+              <a:t>New  —  $149-349/mo  —  enrichment + AI copy engine</a:t>
             </a:r>
           </a:p>
         </p:txBody>
@@ -9427,7 +9427,7 @@
                   <a:srgbClr val="CCCCD8"/>
                 </a:solidFill>
               </a:rPr>
-              <a:t>New  $225 one-time  —  15 sending domains</a:t>
+              <a:t>New  —  $225 one-time  —  15 sending domains (SELLL sets up)</a:t>
             </a:r>
           </a:p>
         </p:txBody>
@@ -9538,7 +9538,7 @@
                   <a:srgbClr val="CCCCD8"/>
                 </a:solidFill>
               </a:rPr>
-              <a:t>New  ~$75/mo  —  15 mailboxes + warmup</a:t>
+              <a:t>New  —  ~$75/mo  —  15 mailboxes + 3-batch warmup (SELLL manages)</a:t>
             </a:r>
           </a:p>
         </p:txBody>
@@ -15994,7 +15994,7 @@
         <p:spPr>
           <a:xfrm>
             <a:off x="585216" y="2980944"/>
-            <a:ext cx="164592" cy="164592"/>
+            <a:ext cx="146304" cy="146304"/>
           </a:xfrm>
           <a:prstGeom prst="rect">
             <a:avLst/>
@@ -16036,8 +16036,8 @@
         </p:nvSpPr>
         <p:spPr>
           <a:xfrm>
-            <a:off x="841248" y="2926080"/>
-            <a:ext cx="5303520" cy="347472"/>
+            <a:off x="822960" y="2926080"/>
+            <a:ext cx="5303520" cy="310896"/>
           </a:xfrm>
           <a:prstGeom prst="rect">
             <a:avLst/>
@@ -16052,12 +16052,12 @@
           <a:p>
             <a:pPr algn="l"/>
             <a:r>
-              <a:rPr sz="950" b="0" i="0">
+              <a:rPr sz="900" b="0" i="0">
                 <a:solidFill>
                   <a:srgbClr val="CCCCD8"/>
                 </a:solidFill>
               </a:rPr>
-              <a:t>5-trigger signal map built for flooring store ICP</a:t>
+              <a:t>15 sending domains via Porkbun  —  $225 one-time (setup by SELLL)</a:t>
             </a:r>
           </a:p>
         </p:txBody>
@@ -16070,8 +16070,8 @@
         </p:nvSpPr>
         <p:spPr>
           <a:xfrm>
-            <a:off x="585216" y="3419856"/>
-            <a:ext cx="164592" cy="164592"/>
+            <a:off x="585216" y="3364992"/>
+            <a:ext cx="146304" cy="146304"/>
           </a:xfrm>
           <a:prstGeom prst="rect">
             <a:avLst/>
@@ -16113,8 +16113,8 @@
         </p:nvSpPr>
         <p:spPr>
           <a:xfrm>
-            <a:off x="841248" y="3364992"/>
-            <a:ext cx="5303520" cy="347472"/>
+            <a:off x="822960" y="3310128"/>
+            <a:ext cx="5303520" cy="310896"/>
           </a:xfrm>
           <a:prstGeom prst="rect">
             <a:avLst/>
@@ -16129,12 +16129,12 @@
           <a:p>
             <a:pPr algn="l"/>
             <a:r>
-              <a:rPr sz="950" b="0" i="0">
+              <a:rPr sz="900" b="0" i="0">
                 <a:solidFill>
                   <a:srgbClr val="CCCCD8"/>
                 </a:solidFill>
               </a:rPr>
-              <a:t>Cold calling as primary channel — SDR dialing daily</a:t>
+              <a:t>15 PremiumInbox mailboxes + 3-batch warmup  —  ~$75/month</a:t>
             </a:r>
           </a:p>
         </p:txBody>
@@ -16147,8 +16147,8 @@
         </p:nvSpPr>
         <p:spPr>
           <a:xfrm>
-            <a:off x="585216" y="3858768"/>
-            <a:ext cx="164592" cy="164592"/>
+            <a:off x="585216" y="3749039"/>
+            <a:ext cx="146304" cy="146304"/>
           </a:xfrm>
           <a:prstGeom prst="rect">
             <a:avLst/>
@@ -16190,8 +16190,8 @@
         </p:nvSpPr>
         <p:spPr>
           <a:xfrm>
-            <a:off x="841248" y="3803904"/>
-            <a:ext cx="5303520" cy="347472"/>
+            <a:off x="822960" y="3694176"/>
+            <a:ext cx="5303520" cy="310896"/>
           </a:xfrm>
           <a:prstGeom prst="rect">
             <a:avLst/>
@@ -16206,12 +16206,12 @@
           <a:p>
             <a:pPr algn="l"/>
             <a:r>
-              <a:rPr sz="950" b="0" i="0">
+              <a:rPr sz="900" b="0" i="0">
                 <a:solidFill>
                   <a:srgbClr val="CCCCD8"/>
                 </a:solidFill>
               </a:rPr>
-              <a:t>5 signal-specific email sequences live in 14 days</a:t>
+              <a:t>Smartlead fully rebuilt: 5 sequences + warmup protocol</a:t>
             </a:r>
           </a:p>
         </p:txBody>
@@ -16224,8 +16224,8 @@
         </p:nvSpPr>
         <p:spPr>
           <a:xfrm>
-            <a:off x="585216" y="4297679"/>
-            <a:ext cx="164592" cy="164592"/>
+            <a:off x="585216" y="4133087"/>
+            <a:ext cx="146304" cy="146304"/>
           </a:xfrm>
           <a:prstGeom prst="rect">
             <a:avLst/>
@@ -16267,8 +16267,8 @@
         </p:nvSpPr>
         <p:spPr>
           <a:xfrm>
-            <a:off x="841248" y="4242816"/>
-            <a:ext cx="5303520" cy="347472"/>
+            <a:off x="822960" y="4078224"/>
+            <a:ext cx="5303520" cy="310896"/>
           </a:xfrm>
           <a:prstGeom prst="rect">
             <a:avLst/>
@@ -16283,12 +16283,12 @@
           <a:p>
             <a:pPr algn="l"/>
             <a:r>
-              <a:rPr sz="950" b="0" i="0">
+              <a:rPr sz="900" b="0" i="0">
                 <a:solidFill>
                   <a:srgbClr val="CCCCD8"/>
                 </a:solidFill>
               </a:rPr>
-              <a:t>LinkedIn enrichment and light sequencing</a:t>
+              <a:t>5-trigger signal map built for your flooring store ICP</a:t>
             </a:r>
           </a:p>
         </p:txBody>
@@ -16301,8 +16301,8 @@
         </p:nvSpPr>
         <p:spPr>
           <a:xfrm>
-            <a:off x="585216" y="4736592"/>
-            <a:ext cx="164592" cy="164592"/>
+            <a:off x="585216" y="4517136"/>
+            <a:ext cx="146304" cy="146304"/>
           </a:xfrm>
           <a:prstGeom prst="rect">
             <a:avLst/>
@@ -16344,8 +16344,8 @@
         </p:nvSpPr>
         <p:spPr>
           <a:xfrm>
-            <a:off x="841248" y="4681728"/>
-            <a:ext cx="5303520" cy="347472"/>
+            <a:off x="822960" y="4462272"/>
+            <a:ext cx="5303520" cy="310896"/>
           </a:xfrm>
           <a:prstGeom prst="rect">
             <a:avLst/>
@@ -16360,12 +16360,12 @@
           <a:p>
             <a:pPr algn="l"/>
             <a:r>
-              <a:rPr sz="950" b="0" i="0">
+              <a:rPr sz="900" b="0" i="0">
                 <a:solidFill>
                   <a:srgbClr val="CCCCD8"/>
                 </a:solidFill>
               </a:rPr>
-              <a:t>Inbound layer on QRFloorGenie website</a:t>
+              <a:t>Dedicated SDR dialing signal-triggered stores daily</a:t>
             </a:r>
           </a:p>
         </p:txBody>
@@ -16378,8 +16378,8 @@
         </p:nvSpPr>
         <p:spPr>
           <a:xfrm>
-            <a:off x="585216" y="5175504"/>
-            <a:ext cx="164592" cy="164592"/>
+            <a:off x="585216" y="4901183"/>
+            <a:ext cx="146304" cy="146304"/>
           </a:xfrm>
           <a:prstGeom prst="rect">
             <a:avLst/>
@@ -16421,8 +16421,8 @@
         </p:nvSpPr>
         <p:spPr>
           <a:xfrm>
-            <a:off x="841248" y="5120640"/>
-            <a:ext cx="5303520" cy="347472"/>
+            <a:off x="822960" y="4846320"/>
+            <a:ext cx="5303520" cy="310896"/>
           </a:xfrm>
           <a:prstGeom prst="rect">
             <a:avLst/>
@@ -16437,12 +16437,12 @@
           <a:p>
             <a:pPr algn="l"/>
             <a:r>
-              <a:rPr sz="950" b="0" i="0">
+              <a:rPr sz="900" b="0" i="0">
                 <a:solidFill>
                   <a:srgbClr val="CCCCD8"/>
                 </a:solidFill>
               </a:rPr>
-              <a:t>Dedicated SDR trained on your product and ICP</a:t>
+              <a:t>Cold calling primary: 40-60 calls/day from Day 8</a:t>
             </a:r>
           </a:p>
         </p:txBody>
@@ -16455,8 +16455,8 @@
         </p:nvSpPr>
         <p:spPr>
           <a:xfrm>
-            <a:off x="585216" y="5614416"/>
-            <a:ext cx="164592" cy="164592"/>
+            <a:off x="585216" y="5285231"/>
+            <a:ext cx="146304" cy="146304"/>
           </a:xfrm>
           <a:prstGeom prst="rect">
             <a:avLst/>
@@ -16498,8 +16498,8 @@
         </p:nvSpPr>
         <p:spPr>
           <a:xfrm>
-            <a:off x="841248" y="5559552"/>
-            <a:ext cx="5303520" cy="347472"/>
+            <a:off x="822960" y="5230368"/>
+            <a:ext cx="5303520" cy="310896"/>
           </a:xfrm>
           <a:prstGeom prst="rect">
             <a:avLst/>
@@ -16514,12 +16514,12 @@
           <a:p>
             <a:pPr algn="l"/>
             <a:r>
-              <a:rPr sz="950" b="0" i="0">
+              <a:rPr sz="900" b="0" i="0">
                 <a:solidFill>
                   <a:srgbClr val="CCCCD8"/>
                 </a:solidFill>
               </a:rPr>
-              <a:t>Weekly reporting: signals, calls, replies, demos</a:t>
+              <a:t>Signal-specific email sequences live within 14 days</a:t>
             </a:r>
           </a:p>
         </p:txBody>
@@ -16532,8 +16532,8 @@
         </p:nvSpPr>
         <p:spPr>
           <a:xfrm>
-            <a:off x="585216" y="6053327"/>
-            <a:ext cx="164592" cy="164592"/>
+            <a:off x="585216" y="5669279"/>
+            <a:ext cx="146304" cy="146304"/>
           </a:xfrm>
           <a:prstGeom prst="rect">
             <a:avLst/>
@@ -16575,8 +16575,8 @@
         </p:nvSpPr>
         <p:spPr>
           <a:xfrm>
-            <a:off x="841248" y="5998464"/>
-            <a:ext cx="5303520" cy="347472"/>
+            <a:off x="822960" y="5614416"/>
+            <a:ext cx="5303520" cy="310896"/>
           </a:xfrm>
           <a:prstGeom prst="rect">
             <a:avLst/>
@@ -16591,12 +16591,12 @@
           <a:p>
             <a:pPr algn="l"/>
             <a:r>
-              <a:rPr sz="950" b="0" i="0">
+              <a:rPr sz="900" b="0" i="0">
                 <a:solidFill>
                   <a:srgbClr val="CCCCD8"/>
                 </a:solidFill>
               </a:rPr>
-              <a:t>Full tech stack managed by SELLL — one invoice</a:t>
+              <a:t>LinkedIn enrichment + trade show sequences</a:t>
             </a:r>
           </a:p>
         </p:txBody>
@@ -16609,14 +16609,14 @@
         </p:nvSpPr>
         <p:spPr>
           <a:xfrm>
-            <a:off x="6601968" y="2340864"/>
-            <a:ext cx="5193792" cy="1975104"/>
-          </a:xfrm>
-          <a:prstGeom prst="rect">
-            <a:avLst/>
-          </a:prstGeom>
-          <a:solidFill>
-            <a:srgbClr val="262640"/>
+            <a:off x="585216" y="6053327"/>
+            <a:ext cx="146304" cy="146304"/>
+          </a:xfrm>
+          <a:prstGeom prst="rect">
+            <a:avLst/>
+          </a:prstGeom>
+          <a:solidFill>
+            <a:srgbClr val="E8B830"/>
           </a:solidFill>
           <a:ln>
             <a:noFill/>
@@ -16646,20 +16646,54 @@
       </p:sp>
       <p:sp>
         <p:nvSpPr>
-          <p:cNvPr id="28" name="Rectangle 27"/>
+          <p:cNvPr id="28" name="TextBox 27"/>
+          <p:cNvSpPr txBox="1"/>
+          <p:nvPr/>
+        </p:nvSpPr>
+        <p:spPr>
+          <a:xfrm>
+            <a:off x="822960" y="5998464"/>
+            <a:ext cx="5303520" cy="310896"/>
+          </a:xfrm>
+          <a:prstGeom prst="rect">
+            <a:avLst/>
+          </a:prstGeom>
+          <a:noFill/>
+        </p:spPr>
+        <p:txBody>
+          <a:bodyPr wrap="square">
+            <a:spAutoFit/>
+          </a:bodyPr>
+          <a:lstStyle/>
+          <a:p>
+            <a:pPr algn="l"/>
+            <a:r>
+              <a:rPr sz="900" b="0" i="0">
+                <a:solidFill>
+                  <a:srgbClr val="CCCCD8"/>
+                </a:solidFill>
+              </a:rPr>
+              <a:t>Weekly reporting: calls, connects, replies, demos booked</a:t>
+            </a:r>
+          </a:p>
+        </p:txBody>
+      </p:sp>
+      <p:sp>
+        <p:nvSpPr>
+          <p:cNvPr id="29" name="Rectangle 28"/>
           <p:cNvSpPr/>
           <p:nvPr/>
         </p:nvSpPr>
         <p:spPr>
           <a:xfrm>
-            <a:off x="6601968" y="2340864"/>
-            <a:ext cx="5193792" cy="45720"/>
-          </a:xfrm>
-          <a:prstGeom prst="rect">
-            <a:avLst/>
-          </a:prstGeom>
-          <a:solidFill>
-            <a:srgbClr val="F0A020"/>
+            <a:off x="585216" y="6437375"/>
+            <a:ext cx="146304" cy="146304"/>
+          </a:xfrm>
+          <a:prstGeom prst="rect">
+            <a:avLst/>
+          </a:prstGeom>
+          <a:solidFill>
+            <a:srgbClr val="E8B830"/>
           </a:solidFill>
           <a:ln>
             <a:noFill/>
@@ -16689,14 +16723,14 @@
       </p:sp>
       <p:sp>
         <p:nvSpPr>
-          <p:cNvPr id="29" name="TextBox 28"/>
-          <p:cNvSpPr txBox="1"/>
-          <p:nvPr/>
-        </p:nvSpPr>
-        <p:spPr>
-          <a:xfrm>
-            <a:off x="6784848" y="2450592"/>
-            <a:ext cx="4754880" cy="310896"/>
+          <p:cNvPr id="30" name="TextBox 29"/>
+          <p:cNvSpPr txBox="1"/>
+          <p:nvPr/>
+        </p:nvSpPr>
+        <p:spPr>
+          <a:xfrm>
+            <a:off x="822960" y="6382512"/>
+            <a:ext cx="5303520" cy="310896"/>
           </a:xfrm>
           <a:prstGeom prst="rect">
             <a:avLst/>
@@ -16711,97 +16745,26 @@
           <a:p>
             <a:pPr algn="l"/>
             <a:r>
-              <a:rPr sz="1000" b="1" i="0">
-                <a:solidFill>
-                  <a:srgbClr val="F0A020"/>
-                </a:solidFill>
-              </a:rPr>
-              <a:t>AFTER 3 MONTHS</a:t>
-            </a:r>
-          </a:p>
-        </p:txBody>
-      </p:sp>
-      <p:sp>
-        <p:nvSpPr>
-          <p:cNvPr id="30" name="TextBox 29"/>
-          <p:cNvSpPr txBox="1"/>
-          <p:nvPr/>
-        </p:nvSpPr>
-        <p:spPr>
-          <a:xfrm>
-            <a:off x="6784848" y="2834640"/>
-            <a:ext cx="4754880" cy="475488"/>
-          </a:xfrm>
-          <a:prstGeom prst="rect">
-            <a:avLst/>
-          </a:prstGeom>
-          <a:noFill/>
-        </p:spPr>
-        <p:txBody>
-          <a:bodyPr wrap="square">
-            <a:spAutoFit/>
-          </a:bodyPr>
-          <a:lstStyle/>
-          <a:p>
-            <a:pPr algn="l"/>
-            <a:r>
-              <a:rPr sz="2200" b="1" i="0">
-                <a:solidFill>
-                  <a:srgbClr val="F0A020"/>
-                </a:solidFill>
-              </a:rPr>
-              <a:t>$2,500/month</a:t>
-            </a:r>
-          </a:p>
-        </p:txBody>
-      </p:sp>
-      <p:sp>
-        <p:nvSpPr>
-          <p:cNvPr id="31" name="TextBox 30"/>
-          <p:cNvSpPr txBox="1"/>
-          <p:nvPr/>
-        </p:nvSpPr>
-        <p:spPr>
-          <a:xfrm>
-            <a:off x="6784848" y="3364992"/>
-            <a:ext cx="4754880" cy="914400"/>
-          </a:xfrm>
-          <a:prstGeom prst="rect">
-            <a:avLst/>
-          </a:prstGeom>
-          <a:noFill/>
-        </p:spPr>
-        <p:txBody>
-          <a:bodyPr wrap="square">
-            <a:spAutoFit/>
-          </a:bodyPr>
-          <a:lstStyle/>
-          <a:p>
-            <a:pPr algn="l"/>
-            <a:r>
               <a:rPr sz="900" b="0" i="0">
                 <a:solidFill>
                   <a:srgbClr val="CCCCD8"/>
                 </a:solidFill>
               </a:rPr>
-              <a:t>SDR retained + trained on all 5 signals
-Full stack maintained by SELLL
-New sequences as market evolves
-SDR role (booking vs closing) — your call</a:t>
-            </a:r>
-          </a:p>
-        </p:txBody>
-      </p:sp>
-      <p:sp>
-        <p:nvSpPr>
-          <p:cNvPr id="32" name="Rectangle 31"/>
+              <a:t>Full SELLL tech stack managed  —  no separate invoices</a:t>
+            </a:r>
+          </a:p>
+        </p:txBody>
+      </p:sp>
+      <p:sp>
+        <p:nvSpPr>
+          <p:cNvPr id="31" name="Rectangle 30"/>
           <p:cNvSpPr/>
           <p:nvPr/>
         </p:nvSpPr>
         <p:spPr>
           <a:xfrm>
-            <a:off x="6601968" y="4462272"/>
-            <a:ext cx="5193792" cy="2066543"/>
+            <a:off x="6601968" y="2340864"/>
+            <a:ext cx="5193792" cy="1975104"/>
           </a:xfrm>
           <a:prstGeom prst="rect">
             <a:avLst/>
@@ -16837,20 +16800,20 @@
       </p:sp>
       <p:sp>
         <p:nvSpPr>
-          <p:cNvPr id="33" name="Rectangle 32"/>
+          <p:cNvPr id="32" name="Rectangle 31"/>
           <p:cNvSpPr/>
           <p:nvPr/>
         </p:nvSpPr>
         <p:spPr>
           <a:xfrm>
-            <a:off x="6601968" y="4462272"/>
+            <a:off x="6601968" y="2340864"/>
             <a:ext cx="5193792" cy="45720"/>
           </a:xfrm>
           <a:prstGeom prst="rect">
             <a:avLst/>
           </a:prstGeom>
           <a:solidFill>
-            <a:srgbClr val="28C870"/>
+            <a:srgbClr val="F0A020"/>
           </a:solidFill>
           <a:ln>
             <a:noFill/>
@@ -16880,7 +16843,198 @@
       </p:sp>
       <p:sp>
         <p:nvSpPr>
+          <p:cNvPr id="33" name="TextBox 32"/>
+          <p:cNvSpPr txBox="1"/>
+          <p:nvPr/>
+        </p:nvSpPr>
+        <p:spPr>
+          <a:xfrm>
+            <a:off x="6784848" y="2450592"/>
+            <a:ext cx="4754880" cy="310896"/>
+          </a:xfrm>
+          <a:prstGeom prst="rect">
+            <a:avLst/>
+          </a:prstGeom>
+          <a:noFill/>
+        </p:spPr>
+        <p:txBody>
+          <a:bodyPr wrap="square">
+            <a:spAutoFit/>
+          </a:bodyPr>
+          <a:lstStyle/>
+          <a:p>
+            <a:pPr algn="l"/>
+            <a:r>
+              <a:rPr sz="1000" b="1" i="0">
+                <a:solidFill>
+                  <a:srgbClr val="F0A020"/>
+                </a:solidFill>
+              </a:rPr>
+              <a:t>AFTER 3 MONTHS</a:t>
+            </a:r>
+          </a:p>
+        </p:txBody>
+      </p:sp>
+      <p:sp>
+        <p:nvSpPr>
           <p:cNvPr id="34" name="TextBox 33"/>
+          <p:cNvSpPr txBox="1"/>
+          <p:nvPr/>
+        </p:nvSpPr>
+        <p:spPr>
+          <a:xfrm>
+            <a:off x="6784848" y="2834640"/>
+            <a:ext cx="4754880" cy="475488"/>
+          </a:xfrm>
+          <a:prstGeom prst="rect">
+            <a:avLst/>
+          </a:prstGeom>
+          <a:noFill/>
+        </p:spPr>
+        <p:txBody>
+          <a:bodyPr wrap="square">
+            <a:spAutoFit/>
+          </a:bodyPr>
+          <a:lstStyle/>
+          <a:p>
+            <a:pPr algn="l"/>
+            <a:r>
+              <a:rPr sz="2200" b="1" i="0">
+                <a:solidFill>
+                  <a:srgbClr val="F0A020"/>
+                </a:solidFill>
+              </a:rPr>
+              <a:t>$2,500/month</a:t>
+            </a:r>
+          </a:p>
+        </p:txBody>
+      </p:sp>
+      <p:sp>
+        <p:nvSpPr>
+          <p:cNvPr id="35" name="TextBox 34"/>
+          <p:cNvSpPr txBox="1"/>
+          <p:nvPr/>
+        </p:nvSpPr>
+        <p:spPr>
+          <a:xfrm>
+            <a:off x="6784848" y="3364992"/>
+            <a:ext cx="4754880" cy="914400"/>
+          </a:xfrm>
+          <a:prstGeom prst="rect">
+            <a:avLst/>
+          </a:prstGeom>
+          <a:noFill/>
+        </p:spPr>
+        <p:txBody>
+          <a:bodyPr wrap="square">
+            <a:spAutoFit/>
+          </a:bodyPr>
+          <a:lstStyle/>
+          <a:p>
+            <a:pPr algn="l"/>
+            <a:r>
+              <a:rPr sz="900" b="0" i="0">
+                <a:solidFill>
+                  <a:srgbClr val="CCCCD8"/>
+                </a:solidFill>
+              </a:rPr>
+              <a:t>SDR retained + trained on all 5 signals
+Full stack maintained by SELLL
+New sequences as market evolves
+SDR role (booking vs closing) — your call</a:t>
+            </a:r>
+          </a:p>
+        </p:txBody>
+      </p:sp>
+      <p:sp>
+        <p:nvSpPr>
+          <p:cNvPr id="36" name="Rectangle 35"/>
+          <p:cNvSpPr/>
+          <p:nvPr/>
+        </p:nvSpPr>
+        <p:spPr>
+          <a:xfrm>
+            <a:off x="6601968" y="4462272"/>
+            <a:ext cx="5193792" cy="2066543"/>
+          </a:xfrm>
+          <a:prstGeom prst="rect">
+            <a:avLst/>
+          </a:prstGeom>
+          <a:solidFill>
+            <a:srgbClr val="262640"/>
+          </a:solidFill>
+          <a:ln>
+            <a:noFill/>
+          </a:ln>
+        </p:spPr>
+        <p:style>
+          <a:lnRef idx="1">
+            <a:schemeClr val="accent1"/>
+          </a:lnRef>
+          <a:fillRef idx="3">
+            <a:schemeClr val="accent1"/>
+          </a:fillRef>
+          <a:effectRef idx="2">
+            <a:schemeClr val="accent1"/>
+          </a:effectRef>
+          <a:fontRef idx="minor">
+            <a:schemeClr val="lt1"/>
+          </a:fontRef>
+        </p:style>
+        <p:txBody>
+          <a:bodyPr rtlCol="0" anchor="ctr"/>
+          <a:lstStyle/>
+          <a:p>
+            <a:pPr algn="ctr"/>
+          </a:p>
+        </p:txBody>
+      </p:sp>
+      <p:sp>
+        <p:nvSpPr>
+          <p:cNvPr id="37" name="Rectangle 36"/>
+          <p:cNvSpPr/>
+          <p:nvPr/>
+        </p:nvSpPr>
+        <p:spPr>
+          <a:xfrm>
+            <a:off x="6601968" y="4462272"/>
+            <a:ext cx="5193792" cy="45720"/>
+          </a:xfrm>
+          <a:prstGeom prst="rect">
+            <a:avLst/>
+          </a:prstGeom>
+          <a:solidFill>
+            <a:srgbClr val="28C870"/>
+          </a:solidFill>
+          <a:ln>
+            <a:noFill/>
+          </a:ln>
+        </p:spPr>
+        <p:style>
+          <a:lnRef idx="1">
+            <a:schemeClr val="accent1"/>
+          </a:lnRef>
+          <a:fillRef idx="3">
+            <a:schemeClr val="accent1"/>
+          </a:fillRef>
+          <a:effectRef idx="2">
+            <a:schemeClr val="accent1"/>
+          </a:effectRef>
+          <a:fontRef idx="minor">
+            <a:schemeClr val="lt1"/>
+          </a:fontRef>
+        </p:style>
+        <p:txBody>
+          <a:bodyPr rtlCol="0" anchor="ctr"/>
+          <a:lstStyle/>
+          <a:p>
+            <a:pPr algn="ctr"/>
+          </a:p>
+        </p:txBody>
+      </p:sp>
+      <p:sp>
+        <p:nvSpPr>
+          <p:cNvPr id="38" name="TextBox 37"/>
           <p:cNvSpPr txBox="1"/>
           <p:nvPr/>
         </p:nvSpPr>
@@ -16914,7 +17068,7 @@
       </p:sp>
       <p:sp>
         <p:nvSpPr>
-          <p:cNvPr id="35" name="TextBox 34"/>
+          <p:cNvPr id="39" name="TextBox 38"/>
           <p:cNvSpPr txBox="1"/>
           <p:nvPr/>
         </p:nvSpPr>
@@ -16950,7 +17104,7 @@
       </p:sp>
       <p:sp>
         <p:nvSpPr>
-          <p:cNvPr id="36" name="TextBox 35"/>
+          <p:cNvPr id="40" name="TextBox 39"/>
           <p:cNvSpPr txBox="1"/>
           <p:nvPr/>
         </p:nvSpPr>
@@ -16984,7 +17138,7 @@
       </p:sp>
       <p:sp>
         <p:nvSpPr>
-          <p:cNvPr id="37" name="TextBox 36"/>
+          <p:cNvPr id="41" name="TextBox 40"/>
           <p:cNvSpPr txBox="1"/>
           <p:nvPr/>
         </p:nvSpPr>

</xml_diff>